<commit_message>
feat: apply three visual fixes + transparent logo asset to value-add pitch deck
- Fix Slide 1: correct full lockup, no white box; rule 5.65, subtitle 5.85, date 6.4 (no overlap)
- Fix Slide 10: roadmap labels shifted up 0.35in, bullets moved 2.0→2.32in, height adjusted ≤6.6in inside 6.75in card
- Fix Slide 13: hero logo centred at (SLIDE_W-2.5)/2=3.75in; art centre 550.0px vs slide centre 550.0px (was 527.5px)
- Add transparent navy-canvas lockup: logo-dark-bg-transparent.png (border-connected flood fill of logo-full.png)
- Update CHANGELOG 1.3.0 with asset + generator change details
- KNOWN-GAPS.md: V06 resolved; V13 still open (requires ls-artifact-qa verdict)
- Generator: _export_dark_logo function + updated add_logo + placement corrections
</commit_message>
<xml_diff>
--- a/static/brand/templates/value-add-pitch-investors-clients.pptx
+++ b/static/brand/templates/value-add-pitch-investors-clients.pptx
@@ -3159,7 +3159,7 @@
         </p:blipFill>
         <p:spPr>
           <a:xfrm>
-            <a:off x="2834640" y="2880360"/>
+            <a:off x="3520440" y="2880360"/>
             <a:ext cx="2103120" cy="2103120"/>
           </a:xfrm>
           <a:prstGeom prst="rect">
@@ -3175,7 +3175,7 @@
         </p:nvSpPr>
         <p:spPr>
           <a:xfrm>
-            <a:off x="3931920" y="4709160"/>
+            <a:off x="3931920" y="5166360"/>
             <a:ext cx="1280160" cy="182880"/>
           </a:xfrm>
           <a:prstGeom prst="rect">
@@ -3218,7 +3218,7 @@
         </p:nvSpPr>
         <p:spPr>
           <a:xfrm>
-            <a:off x="365760" y="4937760"/>
+            <a:off x="365760" y="5349240"/>
             <a:ext cx="8412480" cy="457200"/>
           </a:xfrm>
           <a:prstGeom prst="rect">
@@ -3253,7 +3253,7 @@
         </p:nvSpPr>
         <p:spPr>
           <a:xfrm>
-            <a:off x="365760" y="5440680"/>
+            <a:off x="365760" y="5852160"/>
             <a:ext cx="8412480" cy="365760"/>
           </a:xfrm>
           <a:prstGeom prst="rect">
@@ -3479,7 +3479,7 @@
         <p:spPr>
           <a:xfrm>
             <a:off x="731519" y="1691640"/>
-            <a:ext cx="2377440" cy="365760"/>
+            <a:ext cx="2377440" cy="320040"/>
           </a:xfrm>
           <a:prstGeom prst="rect">
             <a:avLst/>
@@ -3513,8 +3513,8 @@
         </p:nvSpPr>
         <p:spPr>
           <a:xfrm>
-            <a:off x="749808" y="1828800"/>
-            <a:ext cx="2340864" cy="4206240"/>
+            <a:off x="749808" y="2121408"/>
+            <a:ext cx="2340864" cy="3931920"/>
           </a:xfrm>
           <a:prstGeom prst="rect">
             <a:avLst/>
@@ -3719,7 +3719,7 @@
         <p:spPr>
           <a:xfrm>
             <a:off x="3520440" y="1691640"/>
-            <a:ext cx="2377440" cy="365760"/>
+            <a:ext cx="2377440" cy="320040"/>
           </a:xfrm>
           <a:prstGeom prst="rect">
             <a:avLst/>
@@ -3753,8 +3753,8 @@
         </p:nvSpPr>
         <p:spPr>
           <a:xfrm>
-            <a:off x="3538728" y="1828800"/>
-            <a:ext cx="2340864" cy="4206240"/>
+            <a:off x="3538728" y="2121408"/>
+            <a:ext cx="2340864" cy="3931920"/>
           </a:xfrm>
           <a:prstGeom prst="rect">
             <a:avLst/>
@@ -3959,7 +3959,7 @@
         <p:spPr>
           <a:xfrm>
             <a:off x="6309360" y="1691640"/>
-            <a:ext cx="2377440" cy="365760"/>
+            <a:ext cx="2377440" cy="320040"/>
           </a:xfrm>
           <a:prstGeom prst="rect">
             <a:avLst/>
@@ -3993,8 +3993,8 @@
         </p:nvSpPr>
         <p:spPr>
           <a:xfrm>
-            <a:off x="6327648" y="1828800"/>
-            <a:ext cx="2340864" cy="4206240"/>
+            <a:off x="6327648" y="2121408"/>
+            <a:ext cx="2340864" cy="3931920"/>
           </a:xfrm>
           <a:prstGeom prst="rect">
             <a:avLst/>
@@ -6482,7 +6482,7 @@
         </p:blipFill>
         <p:spPr>
           <a:xfrm>
-            <a:off x="3246120" y="3611880"/>
+            <a:off x="3429000" y="3611880"/>
             <a:ext cx="2286000" cy="2286000"/>
           </a:xfrm>
           <a:prstGeom prst="rect">

</xml_diff>